<commit_message>
Add GitHub-release-based update checker (services, UI, FileProvider); bump to 2.1.0
</commit_message>
<xml_diff>
--- a/logo_start.pptx
+++ b/logo_start.pptx
@@ -3335,8 +3335,8 @@
         </p:nvSpPr>
         <p:spPr>
           <a:xfrm>
-            <a:off x="4512574" y="1997291"/>
-            <a:ext cx="3605704" cy="1446550"/>
+            <a:off x="2786748" y="2086252"/>
+            <a:ext cx="6820547" cy="1785104"/>
           </a:xfrm>
           <a:prstGeom prst="rect">
             <a:avLst/>
@@ -3351,7 +3351,18 @@
           <a:p>
             <a:pPr algn="ctr"/>
             <a:r>
-              <a:rPr lang="en-US" sz="8800" dirty="0" err="1">
+              <a:rPr lang="en-US" sz="11000" dirty="0">
+                <a:solidFill>
+                  <a:schemeClr val="accent2">
+                    <a:lumMod val="75000"/>
+                  </a:schemeClr>
+                </a:solidFill>
+                <a:latin typeface="Broadway" panose="04040905080B02020502" pitchFamily="82" charset="0"/>
+              </a:rPr>
+              <a:t>M</a:t>
+            </a:r>
+            <a:r>
+              <a:rPr lang="en-US" sz="11000" dirty="0">
                 <a:solidFill>
                   <a:schemeClr val="accent2">
                     <a:lumMod val="75000"/>
@@ -3362,7 +3373,7 @@
               <a:t>ap</a:t>
             </a:r>
             <a:r>
-              <a:rPr lang="en-US" sz="8800" dirty="0" err="1">
+              <a:rPr lang="en-US" sz="11000" dirty="0">
                 <a:solidFill>
                   <a:srgbClr val="6BA7C9"/>
                 </a:solidFill>
@@ -3370,803 +3381,18 @@
               </a:rPr>
               <a:t>Bana</a:t>
             </a:r>
-            <a:endParaRPr lang="en-US" sz="8800" dirty="0">
-              <a:solidFill>
-                <a:srgbClr val="6BA7C9"/>
-              </a:solidFill>
-              <a:latin typeface="Avenis Semibold" pitchFamily="50" charset="0"/>
-            </a:endParaRPr>
-          </a:p>
-        </p:txBody>
-      </p:sp>
-      <p:pic>
-        <p:nvPicPr>
-          <p:cNvPr id="4" name="Graphic 3" descr="Marker outline">
-            <a:extLst>
-              <a:ext uri="{FF2B5EF4-FFF2-40B4-BE49-F238E27FC236}">
-                <a16:creationId xmlns:a16="http://schemas.microsoft.com/office/drawing/2014/main" id="{7923A32A-202F-45CF-1AA6-086154A6B966}"/>
-              </a:ext>
-            </a:extLst>
-          </p:cNvPr>
-          <p:cNvPicPr>
-            <a:picLocks noChangeAspect="1"/>
-          </p:cNvPicPr>
-          <p:nvPr/>
-        </p:nvPicPr>
-        <p:blipFill>
-          <a:blip>
-            <a:extLst>
-              <a:ext uri="{96DAC541-7B7A-43D3-8B79-37D633B846F1}">
-                <asvg:svgBlip xmlns:asvg="http://schemas.microsoft.com/office/drawing/2016/SVG/main" r:embed="rId2"/>
-              </a:ext>
-            </a:extLst>
-          </a:blip>
-          <a:stretch>
-            <a:fillRect/>
-          </a:stretch>
-        </p:blipFill>
-        <p:spPr>
-          <a:xfrm>
-            <a:off x="7813859" y="2220509"/>
-            <a:ext cx="914400" cy="914400"/>
-          </a:xfrm>
-          <a:prstGeom prst="rect">
-            <a:avLst/>
-          </a:prstGeom>
-        </p:spPr>
-      </p:pic>
-      <p:sp>
-        <p:nvSpPr>
-          <p:cNvPr id="5" name="Oval 4">
-            <a:extLst>
-              <a:ext uri="{FF2B5EF4-FFF2-40B4-BE49-F238E27FC236}">
-                <a16:creationId xmlns:a16="http://schemas.microsoft.com/office/drawing/2014/main" id="{E6513EE8-9F25-7F85-ECAB-BD7208D04074}"/>
-              </a:ext>
-            </a:extLst>
-          </p:cNvPr>
-          <p:cNvSpPr/>
-          <p:nvPr/>
-        </p:nvSpPr>
-        <p:spPr>
-          <a:xfrm>
-            <a:off x="8205537" y="3068053"/>
-            <a:ext cx="144379" cy="156410"/>
-          </a:xfrm>
-          <a:prstGeom prst="ellipse">
-            <a:avLst/>
-          </a:prstGeom>
-          <a:solidFill>
-            <a:srgbClr val="6BA7C9"/>
-          </a:solidFill>
-          <a:ln>
-            <a:solidFill>
-              <a:srgbClr val="6BA7C9"/>
-            </a:solidFill>
-          </a:ln>
-        </p:spPr>
-        <p:style>
-          <a:lnRef idx="2">
-            <a:schemeClr val="accent1">
-              <a:shade val="15000"/>
-            </a:schemeClr>
-          </a:lnRef>
-          <a:fillRef idx="1">
-            <a:schemeClr val="accent1"/>
-          </a:fillRef>
-          <a:effectRef idx="0">
-            <a:schemeClr val="accent1"/>
-          </a:effectRef>
-          <a:fontRef idx="minor">
-            <a:schemeClr val="lt1"/>
-          </a:fontRef>
-        </p:style>
-        <p:txBody>
-          <a:bodyPr rtlCol="0" anchor="ctr"/>
-          <a:lstStyle/>
-          <a:p>
-            <a:pPr algn="ctr"/>
-            <a:endParaRPr lang="en-US"/>
-          </a:p>
-        </p:txBody>
-      </p:sp>
-      <p:grpSp>
-        <p:nvGrpSpPr>
-          <p:cNvPr id="8" name="Graphic 6" descr="Map with pin outline">
-            <a:extLst>
-              <a:ext uri="{FF2B5EF4-FFF2-40B4-BE49-F238E27FC236}">
-                <a16:creationId xmlns:a16="http://schemas.microsoft.com/office/drawing/2014/main" id="{659ADE6F-3331-6D39-4CEA-A4C5BF7A9226}"/>
-              </a:ext>
-            </a:extLst>
-          </p:cNvPr>
-          <p:cNvGrpSpPr/>
-          <p:nvPr/>
-        </p:nvGrpSpPr>
-        <p:grpSpPr>
-          <a:xfrm>
-            <a:off x="3413760" y="2173352"/>
-            <a:ext cx="1098814" cy="1008713"/>
-            <a:chOff x="3378356" y="2391616"/>
-            <a:chExt cx="1031106" cy="837606"/>
-          </a:xfrm>
-          <a:solidFill>
-            <a:srgbClr val="C04F15"/>
-          </a:solidFill>
-        </p:grpSpPr>
-        <p:sp>
-          <p:nvSpPr>
-            <p:cNvPr id="9" name="Freeform: Shape 8">
-              <a:extLst>
-                <a:ext uri="{FF2B5EF4-FFF2-40B4-BE49-F238E27FC236}">
-                  <a16:creationId xmlns:a16="http://schemas.microsoft.com/office/drawing/2014/main" id="{1BE7FC25-78E9-D30B-DED1-1B7802F16ACA}"/>
-                </a:ext>
-              </a:extLst>
-            </p:cNvPr>
-            <p:cNvSpPr/>
-            <p:nvPr/>
-          </p:nvSpPr>
-          <p:spPr>
-            <a:xfrm>
-              <a:off x="3378356" y="2507448"/>
-              <a:ext cx="1031106" cy="721774"/>
-            </a:xfrm>
-            <a:custGeom>
-              <a:avLst/>
-              <a:gdLst>
-                <a:gd name="csX0" fmla="*/ 932971 w 1031106"/>
-                <a:gd name="csY0" fmla="*/ 79833 h 721774"/>
-                <a:gd name="csX1" fmla="*/ 922338 w 1031106"/>
-                <a:gd name="csY1" fmla="*/ 103330 h 721774"/>
-                <a:gd name="csX2" fmla="*/ 1005329 w 1031106"/>
-                <a:gd name="csY2" fmla="*/ 144819 h 721774"/>
-                <a:gd name="csX3" fmla="*/ 1005329 w 1031106"/>
-                <a:gd name="csY3" fmla="*/ 680066 h 721774"/>
-                <a:gd name="csX4" fmla="*/ 786219 w 1031106"/>
-                <a:gd name="csY4" fmla="*/ 570511 h 721774"/>
-                <a:gd name="csX5" fmla="*/ 786219 w 1031106"/>
-                <a:gd name="csY5" fmla="*/ 354443 h 721774"/>
-                <a:gd name="csX6" fmla="*/ 760441 w 1031106"/>
-                <a:gd name="csY6" fmla="*/ 354443 h 721774"/>
-                <a:gd name="csX7" fmla="*/ 760441 w 1031106"/>
-                <a:gd name="csY7" fmla="*/ 570511 h 721774"/>
-                <a:gd name="csX8" fmla="*/ 528442 w 1031106"/>
-                <a:gd name="csY8" fmla="*/ 686511 h 721774"/>
-                <a:gd name="csX9" fmla="*/ 528442 w 1031106"/>
-                <a:gd name="csY9" fmla="*/ 151263 h 721774"/>
-                <a:gd name="csX10" fmla="*/ 623562 w 1031106"/>
-                <a:gd name="csY10" fmla="*/ 103704 h 721774"/>
-                <a:gd name="csX11" fmla="*/ 612916 w 1031106"/>
-                <a:gd name="csY11" fmla="*/ 80207 h 721774"/>
-                <a:gd name="csX12" fmla="*/ 515553 w 1031106"/>
-                <a:gd name="csY12" fmla="*/ 128888 h 721774"/>
-                <a:gd name="csX13" fmla="*/ 257777 w 1031106"/>
-                <a:gd name="csY13" fmla="*/ 0 h 721774"/>
-                <a:gd name="csX14" fmla="*/ 0 w 1031106"/>
-                <a:gd name="csY14" fmla="*/ 128888 h 721774"/>
-                <a:gd name="csX15" fmla="*/ 0 w 1031106"/>
-                <a:gd name="csY15" fmla="*/ 721775 h 721774"/>
-                <a:gd name="csX16" fmla="*/ 257777 w 1031106"/>
-                <a:gd name="csY16" fmla="*/ 592886 h 721774"/>
-                <a:gd name="csX17" fmla="*/ 515553 w 1031106"/>
-                <a:gd name="csY17" fmla="*/ 721775 h 721774"/>
-                <a:gd name="csX18" fmla="*/ 773330 w 1031106"/>
-                <a:gd name="csY18" fmla="*/ 592886 h 721774"/>
-                <a:gd name="csX19" fmla="*/ 1031107 w 1031106"/>
-                <a:gd name="csY19" fmla="*/ 721775 h 721774"/>
-                <a:gd name="csX20" fmla="*/ 1031107 w 1031106"/>
-                <a:gd name="csY20" fmla="*/ 128888 h 721774"/>
-                <a:gd name="csX21" fmla="*/ 244888 w 1031106"/>
-                <a:gd name="csY21" fmla="*/ 570511 h 721774"/>
-                <a:gd name="csX22" fmla="*/ 25778 w 1031106"/>
-                <a:gd name="csY22" fmla="*/ 680066 h 721774"/>
-                <a:gd name="csX23" fmla="*/ 25778 w 1031106"/>
-                <a:gd name="csY23" fmla="*/ 144819 h 721774"/>
-                <a:gd name="csX24" fmla="*/ 244888 w 1031106"/>
-                <a:gd name="csY24" fmla="*/ 35264 h 721774"/>
-                <a:gd name="csX25" fmla="*/ 502665 w 1031106"/>
-                <a:gd name="csY25" fmla="*/ 686511 h 721774"/>
-                <a:gd name="csX26" fmla="*/ 270666 w 1031106"/>
-                <a:gd name="csY26" fmla="*/ 570511 h 721774"/>
-                <a:gd name="csX27" fmla="*/ 270666 w 1031106"/>
-                <a:gd name="csY27" fmla="*/ 35264 h 721774"/>
-                <a:gd name="csX28" fmla="*/ 502665 w 1031106"/>
-                <a:gd name="csY28" fmla="*/ 151263 h 721774"/>
-              </a:gdLst>
-              <a:ahLst/>
-              <a:cxnLst>
-                <a:cxn ang="0">
-                  <a:pos x="csX0" y="csY0"/>
-                </a:cxn>
-                <a:cxn ang="0">
-                  <a:pos x="csX1" y="csY1"/>
-                </a:cxn>
-                <a:cxn ang="0">
-                  <a:pos x="csX2" y="csY2"/>
-                </a:cxn>
-                <a:cxn ang="0">
-                  <a:pos x="csX3" y="csY3"/>
-                </a:cxn>
-                <a:cxn ang="0">
-                  <a:pos x="csX4" y="csY4"/>
-                </a:cxn>
-                <a:cxn ang="0">
-                  <a:pos x="csX5" y="csY5"/>
-                </a:cxn>
-                <a:cxn ang="0">
-                  <a:pos x="csX6" y="csY6"/>
-                </a:cxn>
-                <a:cxn ang="0">
-                  <a:pos x="csX7" y="csY7"/>
-                </a:cxn>
-                <a:cxn ang="0">
-                  <a:pos x="csX8" y="csY8"/>
-                </a:cxn>
-                <a:cxn ang="0">
-                  <a:pos x="csX9" y="csY9"/>
-                </a:cxn>
-                <a:cxn ang="0">
-                  <a:pos x="csX10" y="csY10"/>
-                </a:cxn>
-                <a:cxn ang="0">
-                  <a:pos x="csX11" y="csY11"/>
-                </a:cxn>
-                <a:cxn ang="0">
-                  <a:pos x="csX12" y="csY12"/>
-                </a:cxn>
-                <a:cxn ang="0">
-                  <a:pos x="csX13" y="csY13"/>
-                </a:cxn>
-                <a:cxn ang="0">
-                  <a:pos x="csX14" y="csY14"/>
-                </a:cxn>
-                <a:cxn ang="0">
-                  <a:pos x="csX15" y="csY15"/>
-                </a:cxn>
-                <a:cxn ang="0">
-                  <a:pos x="csX16" y="csY16"/>
-                </a:cxn>
-                <a:cxn ang="0">
-                  <a:pos x="csX17" y="csY17"/>
-                </a:cxn>
-                <a:cxn ang="0">
-                  <a:pos x="csX18" y="csY18"/>
-                </a:cxn>
-                <a:cxn ang="0">
-                  <a:pos x="csX19" y="csY19"/>
-                </a:cxn>
-                <a:cxn ang="0">
-                  <a:pos x="csX20" y="csY20"/>
-                </a:cxn>
-                <a:cxn ang="0">
-                  <a:pos x="csX21" y="csY21"/>
-                </a:cxn>
-                <a:cxn ang="0">
-                  <a:pos x="csX22" y="csY22"/>
-                </a:cxn>
-                <a:cxn ang="0">
-                  <a:pos x="csX23" y="csY23"/>
-                </a:cxn>
-                <a:cxn ang="0">
-                  <a:pos x="csX24" y="csY24"/>
-                </a:cxn>
-                <a:cxn ang="0">
-                  <a:pos x="csX25" y="csY25"/>
-                </a:cxn>
-                <a:cxn ang="0">
-                  <a:pos x="csX26" y="csY26"/>
-                </a:cxn>
-                <a:cxn ang="0">
-                  <a:pos x="csX27" y="csY27"/>
-                </a:cxn>
-                <a:cxn ang="0">
-                  <a:pos x="csX28" y="csY28"/>
-                </a:cxn>
-              </a:cxnLst>
-              <a:rect l="l" t="t" r="r" b="b"/>
-              <a:pathLst>
-                <a:path w="1031106" h="721774">
-                  <a:moveTo>
-                    <a:pt x="932971" y="79833"/>
-                  </a:moveTo>
-                  <a:lnTo>
-                    <a:pt x="922338" y="103330"/>
-                  </a:lnTo>
-                  <a:lnTo>
-                    <a:pt x="1005329" y="144819"/>
-                  </a:lnTo>
-                  <a:lnTo>
-                    <a:pt x="1005329" y="680066"/>
-                  </a:lnTo>
-                  <a:lnTo>
-                    <a:pt x="786219" y="570511"/>
-                  </a:lnTo>
-                  <a:lnTo>
-                    <a:pt x="786219" y="354443"/>
-                  </a:lnTo>
-                  <a:lnTo>
-                    <a:pt x="760441" y="354443"/>
-                  </a:lnTo>
-                  <a:lnTo>
-                    <a:pt x="760441" y="570511"/>
-                  </a:lnTo>
-                  <a:lnTo>
-                    <a:pt x="528442" y="686511"/>
-                  </a:lnTo>
-                  <a:lnTo>
-                    <a:pt x="528442" y="151263"/>
-                  </a:lnTo>
-                  <a:lnTo>
-                    <a:pt x="623562" y="103704"/>
-                  </a:lnTo>
-                  <a:lnTo>
-                    <a:pt x="612916" y="80207"/>
-                  </a:lnTo>
-                  <a:lnTo>
-                    <a:pt x="515553" y="128888"/>
-                  </a:lnTo>
-                  <a:lnTo>
-                    <a:pt x="257777" y="0"/>
-                  </a:lnTo>
-                  <a:lnTo>
-                    <a:pt x="0" y="128888"/>
-                  </a:lnTo>
-                  <a:lnTo>
-                    <a:pt x="0" y="721775"/>
-                  </a:lnTo>
-                  <a:lnTo>
-                    <a:pt x="257777" y="592886"/>
-                  </a:lnTo>
-                  <a:lnTo>
-                    <a:pt x="515553" y="721775"/>
-                  </a:lnTo>
-                  <a:lnTo>
-                    <a:pt x="773330" y="592886"/>
-                  </a:lnTo>
-                  <a:lnTo>
-                    <a:pt x="1031107" y="721775"/>
-                  </a:lnTo>
-                  <a:lnTo>
-                    <a:pt x="1031107" y="128888"/>
-                  </a:lnTo>
-                  <a:close/>
-                  <a:moveTo>
-                    <a:pt x="244888" y="570511"/>
-                  </a:moveTo>
-                  <a:lnTo>
-                    <a:pt x="25778" y="680066"/>
-                  </a:lnTo>
-                  <a:lnTo>
-                    <a:pt x="25778" y="144819"/>
-                  </a:lnTo>
-                  <a:lnTo>
-                    <a:pt x="244888" y="35264"/>
-                  </a:lnTo>
-                  <a:close/>
-                  <a:moveTo>
-                    <a:pt x="502665" y="686511"/>
-                  </a:moveTo>
-                  <a:lnTo>
-                    <a:pt x="270666" y="570511"/>
-                  </a:lnTo>
-                  <a:lnTo>
-                    <a:pt x="270666" y="35264"/>
-                  </a:lnTo>
-                  <a:lnTo>
-                    <a:pt x="502665" y="151263"/>
-                  </a:lnTo>
-                  <a:close/>
-                </a:path>
-              </a:pathLst>
-            </a:custGeom>
-            <a:grpFill/>
-            <a:ln w="12799" cap="flat">
-              <a:solidFill>
-                <a:srgbClr val="C04F15"/>
-              </a:solidFill>
-              <a:prstDash val="solid"/>
-              <a:miter/>
-            </a:ln>
-          </p:spPr>
-          <p:txBody>
-            <a:bodyPr/>
-            <a:lstStyle/>
-            <a:p>
-              <a:endParaRPr lang="en-US"/>
-            </a:p>
-          </p:txBody>
-        </p:sp>
-        <p:sp>
-          <p:nvSpPr>
-            <p:cNvPr id="10" name="Freeform: Shape 9">
-              <a:extLst>
-                <a:ext uri="{FF2B5EF4-FFF2-40B4-BE49-F238E27FC236}">
-                  <a16:creationId xmlns:a16="http://schemas.microsoft.com/office/drawing/2014/main" id="{AF3E2941-A85E-A624-8DCF-5E11E7255B38}"/>
-                </a:ext>
-              </a:extLst>
-            </p:cNvPr>
-            <p:cNvSpPr/>
-            <p:nvPr/>
-          </p:nvSpPr>
-          <p:spPr>
-            <a:xfrm>
-              <a:off x="4018401" y="2391616"/>
-              <a:ext cx="265749" cy="431511"/>
-            </a:xfrm>
-            <a:custGeom>
-              <a:avLst/>
-              <a:gdLst>
-                <a:gd name="csX0" fmla="*/ 132808 w 265749"/>
-                <a:gd name="csY0" fmla="*/ 25778 h 431511"/>
-                <a:gd name="csX1" fmla="*/ 221341 w 265749"/>
-                <a:gd name="csY1" fmla="*/ 72951 h 431511"/>
-                <a:gd name="csX2" fmla="*/ 232774 w 265749"/>
-                <a:gd name="csY2" fmla="*/ 172195 h 431511"/>
-                <a:gd name="csX3" fmla="*/ 173008 w 265749"/>
-                <a:gd name="csY3" fmla="*/ 304305 h 431511"/>
-                <a:gd name="csX4" fmla="*/ 132808 w 265749"/>
-                <a:gd name="csY4" fmla="*/ 388689 h 431511"/>
-                <a:gd name="csX5" fmla="*/ 92852 w 265749"/>
-                <a:gd name="csY5" fmla="*/ 304834 h 431511"/>
-                <a:gd name="csX6" fmla="*/ 32855 w 265749"/>
-                <a:gd name="csY6" fmla="*/ 172246 h 431511"/>
-                <a:gd name="csX7" fmla="*/ 44455 w 265749"/>
-                <a:gd name="csY7" fmla="*/ 72783 h 431511"/>
-                <a:gd name="csX8" fmla="*/ 132872 w 265749"/>
-                <a:gd name="csY8" fmla="*/ 25778 h 431511"/>
-                <a:gd name="csX9" fmla="*/ 132872 w 265749"/>
-                <a:gd name="csY9" fmla="*/ 0 h 431511"/>
-                <a:gd name="csX10" fmla="*/ 23072 w 265749"/>
-                <a:gd name="csY10" fmla="*/ 58399 h 431511"/>
-                <a:gd name="csX11" fmla="*/ 9101 w 265749"/>
-                <a:gd name="csY11" fmla="*/ 182132 h 431511"/>
-                <a:gd name="csX12" fmla="*/ 69408 w 265749"/>
-                <a:gd name="csY12" fmla="*/ 315429 h 431511"/>
-                <a:gd name="csX13" fmla="*/ 121453 w 265749"/>
-                <a:gd name="csY13" fmla="*/ 424597 h 431511"/>
-                <a:gd name="csX14" fmla="*/ 138849 w 265749"/>
-                <a:gd name="csY14" fmla="*/ 430040 h 431511"/>
-                <a:gd name="csX15" fmla="*/ 144292 w 265749"/>
-                <a:gd name="csY15" fmla="*/ 424597 h 431511"/>
-                <a:gd name="csX16" fmla="*/ 196350 w 265749"/>
-                <a:gd name="csY16" fmla="*/ 315429 h 431511"/>
-                <a:gd name="csX17" fmla="*/ 256644 w 265749"/>
-                <a:gd name="csY17" fmla="*/ 182132 h 431511"/>
-                <a:gd name="csX18" fmla="*/ 242685 w 265749"/>
-                <a:gd name="csY18" fmla="*/ 58399 h 431511"/>
-                <a:gd name="csX19" fmla="*/ 132872 w 265749"/>
-                <a:gd name="csY19" fmla="*/ 0 h 431511"/>
-              </a:gdLst>
-              <a:ahLst/>
-              <a:cxnLst>
-                <a:cxn ang="0">
-                  <a:pos x="csX0" y="csY0"/>
-                </a:cxn>
-                <a:cxn ang="0">
-                  <a:pos x="csX1" y="csY1"/>
-                </a:cxn>
-                <a:cxn ang="0">
-                  <a:pos x="csX2" y="csY2"/>
-                </a:cxn>
-                <a:cxn ang="0">
-                  <a:pos x="csX3" y="csY3"/>
-                </a:cxn>
-                <a:cxn ang="0">
-                  <a:pos x="csX4" y="csY4"/>
-                </a:cxn>
-                <a:cxn ang="0">
-                  <a:pos x="csX5" y="csY5"/>
-                </a:cxn>
-                <a:cxn ang="0">
-                  <a:pos x="csX6" y="csY6"/>
-                </a:cxn>
-                <a:cxn ang="0">
-                  <a:pos x="csX7" y="csY7"/>
-                </a:cxn>
-                <a:cxn ang="0">
-                  <a:pos x="csX8" y="csY8"/>
-                </a:cxn>
-                <a:cxn ang="0">
-                  <a:pos x="csX9" y="csY9"/>
-                </a:cxn>
-                <a:cxn ang="0">
-                  <a:pos x="csX10" y="csY10"/>
-                </a:cxn>
-                <a:cxn ang="0">
-                  <a:pos x="csX11" y="csY11"/>
-                </a:cxn>
-                <a:cxn ang="0">
-                  <a:pos x="csX12" y="csY12"/>
-                </a:cxn>
-                <a:cxn ang="0">
-                  <a:pos x="csX13" y="csY13"/>
-                </a:cxn>
-                <a:cxn ang="0">
-                  <a:pos x="csX14" y="csY14"/>
-                </a:cxn>
-                <a:cxn ang="0">
-                  <a:pos x="csX15" y="csY15"/>
-                </a:cxn>
-                <a:cxn ang="0">
-                  <a:pos x="csX16" y="csY16"/>
-                </a:cxn>
-                <a:cxn ang="0">
-                  <a:pos x="csX17" y="csY17"/>
-                </a:cxn>
-                <a:cxn ang="0">
-                  <a:pos x="csX18" y="csY18"/>
-                </a:cxn>
-                <a:cxn ang="0">
-                  <a:pos x="csX19" y="csY19"/>
-                </a:cxn>
-              </a:cxnLst>
-              <a:rect l="l" t="t" r="r" b="b"/>
-              <a:pathLst>
-                <a:path w="265749" h="431511">
-                  <a:moveTo>
-                    <a:pt x="132808" y="25778"/>
-                  </a:moveTo>
-                  <a:cubicBezTo>
-                    <a:pt x="168344" y="25737"/>
-                    <a:pt x="201556" y="43433"/>
-                    <a:pt x="221341" y="72951"/>
-                  </a:cubicBezTo>
-                  <a:cubicBezTo>
-                    <a:pt x="241118" y="102185"/>
-                    <a:pt x="245385" y="139230"/>
-                    <a:pt x="232774" y="172195"/>
-                  </a:cubicBezTo>
-                  <a:lnTo>
-                    <a:pt x="173008" y="304305"/>
-                  </a:lnTo>
-                  <a:lnTo>
-                    <a:pt x="132808" y="388689"/>
-                  </a:lnTo>
-                  <a:lnTo>
-                    <a:pt x="92852" y="304834"/>
-                  </a:lnTo>
-                  <a:lnTo>
-                    <a:pt x="32855" y="172246"/>
-                  </a:lnTo>
-                  <a:cubicBezTo>
-                    <a:pt x="20235" y="139189"/>
-                    <a:pt x="24566" y="102050"/>
-                    <a:pt x="44455" y="72783"/>
-                  </a:cubicBezTo>
-                  <a:cubicBezTo>
-                    <a:pt x="64243" y="43349"/>
-                    <a:pt x="97405" y="25720"/>
-                    <a:pt x="132872" y="25778"/>
-                  </a:cubicBezTo>
-                  <a:moveTo>
-                    <a:pt x="132872" y="0"/>
-                  </a:moveTo>
-                  <a:cubicBezTo>
-                    <a:pt x="88827" y="-46"/>
-                    <a:pt x="47655" y="21853"/>
-                    <a:pt x="23072" y="58399"/>
-                  </a:cubicBezTo>
-                  <a:cubicBezTo>
-                    <a:pt x="-1621" y="94846"/>
-                    <a:pt x="-6844" y="141097"/>
-                    <a:pt x="9101" y="182132"/>
-                  </a:cubicBezTo>
-                  <a:lnTo>
-                    <a:pt x="69408" y="315429"/>
-                  </a:lnTo>
-                  <a:lnTo>
-                    <a:pt x="121453" y="424597"/>
-                  </a:lnTo>
-                  <a:cubicBezTo>
-                    <a:pt x="124754" y="430903"/>
-                    <a:pt x="132542" y="433341"/>
-                    <a:pt x="138849" y="430040"/>
-                  </a:cubicBezTo>
-                  <a:cubicBezTo>
-                    <a:pt x="141175" y="428822"/>
-                    <a:pt x="143074" y="426923"/>
-                    <a:pt x="144292" y="424597"/>
-                  </a:cubicBezTo>
-                  <a:lnTo>
-                    <a:pt x="196350" y="315429"/>
-                  </a:lnTo>
-                  <a:lnTo>
-                    <a:pt x="256644" y="182132"/>
-                  </a:lnTo>
-                  <a:cubicBezTo>
-                    <a:pt x="272592" y="141098"/>
-                    <a:pt x="267375" y="94849"/>
-                    <a:pt x="242685" y="58399"/>
-                  </a:cubicBezTo>
-                  <a:cubicBezTo>
-                    <a:pt x="218096" y="21854"/>
-                    <a:pt x="176920" y="-44"/>
-                    <a:pt x="132872" y="0"/>
-                  </a:cubicBezTo>
-                  <a:close/>
-                </a:path>
-              </a:pathLst>
-            </a:custGeom>
-            <a:grpFill/>
-            <a:ln w="12799" cap="flat">
-              <a:solidFill>
-                <a:srgbClr val="C04F15"/>
-              </a:solidFill>
-              <a:prstDash val="solid"/>
-              <a:miter/>
-            </a:ln>
-          </p:spPr>
-          <p:txBody>
-            <a:bodyPr/>
-            <a:lstStyle/>
-            <a:p>
-              <a:endParaRPr lang="en-US"/>
-            </a:p>
-          </p:txBody>
-        </p:sp>
-        <p:sp>
-          <p:nvSpPr>
-            <p:cNvPr id="11" name="Freeform: Shape 10">
-              <a:extLst>
-                <a:ext uri="{FF2B5EF4-FFF2-40B4-BE49-F238E27FC236}">
-                  <a16:creationId xmlns:a16="http://schemas.microsoft.com/office/drawing/2014/main" id="{DC85786F-47F9-00F9-657C-E5F026C51D59}"/>
-                </a:ext>
-              </a:extLst>
-            </p:cNvPr>
-            <p:cNvSpPr/>
-            <p:nvPr/>
-          </p:nvSpPr>
-          <p:spPr>
-            <a:xfrm>
-              <a:off x="4094150" y="2467788"/>
-              <a:ext cx="114247" cy="114247"/>
-            </a:xfrm>
-            <a:custGeom>
-              <a:avLst/>
-              <a:gdLst>
-                <a:gd name="csX0" fmla="*/ 57059 w 114247"/>
-                <a:gd name="csY0" fmla="*/ 25779 h 114247"/>
-                <a:gd name="csX1" fmla="*/ 88405 w 114247"/>
-                <a:gd name="csY1" fmla="*/ 57124 h 114247"/>
-                <a:gd name="csX2" fmla="*/ 57059 w 114247"/>
-                <a:gd name="csY2" fmla="*/ 88470 h 114247"/>
-                <a:gd name="csX3" fmla="*/ 25713 w 114247"/>
-                <a:gd name="csY3" fmla="*/ 57124 h 114247"/>
-                <a:gd name="csX4" fmla="*/ 56385 w 114247"/>
-                <a:gd name="csY4" fmla="*/ 25779 h 114247"/>
-                <a:gd name="csX5" fmla="*/ 57059 w 114247"/>
-                <a:gd name="csY5" fmla="*/ 25779 h 114247"/>
-                <a:gd name="csX6" fmla="*/ 57059 w 114247"/>
-                <a:gd name="csY6" fmla="*/ 1 h 114247"/>
-                <a:gd name="csX7" fmla="*/ 0 w 114247"/>
-                <a:gd name="csY7" fmla="*/ 57189 h 114247"/>
-                <a:gd name="csX8" fmla="*/ 57188 w 114247"/>
-                <a:gd name="csY8" fmla="*/ 114248 h 114247"/>
-                <a:gd name="csX9" fmla="*/ 114247 w 114247"/>
-                <a:gd name="csY9" fmla="*/ 57124 h 114247"/>
-                <a:gd name="csX10" fmla="*/ 57614 w 114247"/>
-                <a:gd name="csY10" fmla="*/ 1 h 114247"/>
-                <a:gd name="csX11" fmla="*/ 57123 w 114247"/>
-                <a:gd name="csY11" fmla="*/ 1 h 114247"/>
-              </a:gdLst>
-              <a:ahLst/>
-              <a:cxnLst>
-                <a:cxn ang="0">
-                  <a:pos x="csX0" y="csY0"/>
-                </a:cxn>
-                <a:cxn ang="0">
-                  <a:pos x="csX1" y="csY1"/>
-                </a:cxn>
-                <a:cxn ang="0">
-                  <a:pos x="csX2" y="csY2"/>
-                </a:cxn>
-                <a:cxn ang="0">
-                  <a:pos x="csX3" y="csY3"/>
-                </a:cxn>
-                <a:cxn ang="0">
-                  <a:pos x="csX4" y="csY4"/>
-                </a:cxn>
-                <a:cxn ang="0">
-                  <a:pos x="csX5" y="csY5"/>
-                </a:cxn>
-                <a:cxn ang="0">
-                  <a:pos x="csX6" y="csY6"/>
-                </a:cxn>
-                <a:cxn ang="0">
-                  <a:pos x="csX7" y="csY7"/>
-                </a:cxn>
-                <a:cxn ang="0">
-                  <a:pos x="csX8" y="csY8"/>
-                </a:cxn>
-                <a:cxn ang="0">
-                  <a:pos x="csX9" y="csY9"/>
-                </a:cxn>
-                <a:cxn ang="0">
-                  <a:pos x="csX10" y="csY10"/>
-                </a:cxn>
-                <a:cxn ang="0">
-                  <a:pos x="csX11" y="csY11"/>
-                </a:cxn>
-              </a:cxnLst>
-              <a:rect l="l" t="t" r="r" b="b"/>
-              <a:pathLst>
-                <a:path w="114247" h="114247">
-                  <a:moveTo>
-                    <a:pt x="57059" y="25779"/>
-                  </a:moveTo>
-                  <a:cubicBezTo>
-                    <a:pt x="74371" y="25779"/>
-                    <a:pt x="88405" y="39812"/>
-                    <a:pt x="88405" y="57124"/>
-                  </a:cubicBezTo>
-                  <a:cubicBezTo>
-                    <a:pt x="88405" y="74437"/>
-                    <a:pt x="74371" y="88470"/>
-                    <a:pt x="57059" y="88470"/>
-                  </a:cubicBezTo>
-                  <a:cubicBezTo>
-                    <a:pt x="39747" y="88470"/>
-                    <a:pt x="25713" y="74437"/>
-                    <a:pt x="25713" y="57124"/>
-                  </a:cubicBezTo>
-                  <a:cubicBezTo>
-                    <a:pt x="25528" y="39999"/>
-                    <a:pt x="39259" y="25964"/>
-                    <a:pt x="56385" y="25779"/>
-                  </a:cubicBezTo>
-                  <a:cubicBezTo>
-                    <a:pt x="56609" y="25776"/>
-                    <a:pt x="56835" y="25776"/>
-                    <a:pt x="57059" y="25779"/>
-                  </a:cubicBezTo>
-                  <a:moveTo>
-                    <a:pt x="57059" y="1"/>
-                  </a:moveTo>
-                  <a:cubicBezTo>
-                    <a:pt x="25511" y="37"/>
-                    <a:pt x="-36" y="25641"/>
-                    <a:pt x="0" y="57189"/>
-                  </a:cubicBezTo>
-                  <a:cubicBezTo>
-                    <a:pt x="36" y="88737"/>
-                    <a:pt x="25640" y="114284"/>
-                    <a:pt x="57188" y="114248"/>
-                  </a:cubicBezTo>
-                  <a:cubicBezTo>
-                    <a:pt x="88711" y="114212"/>
-                    <a:pt x="114247" y="88648"/>
-                    <a:pt x="114247" y="57124"/>
-                  </a:cubicBezTo>
-                  <a:cubicBezTo>
-                    <a:pt x="114382" y="25712"/>
-                    <a:pt x="89027" y="136"/>
-                    <a:pt x="57614" y="1"/>
-                  </a:cubicBezTo>
-                  <a:cubicBezTo>
-                    <a:pt x="57451" y="0"/>
-                    <a:pt x="57287" y="0"/>
-                    <a:pt x="57123" y="1"/>
-                  </a:cubicBezTo>
-                  <a:close/>
-                </a:path>
-              </a:pathLst>
-            </a:custGeom>
-            <a:grpFill/>
-            <a:ln w="12799" cap="flat">
-              <a:solidFill>
-                <a:srgbClr val="C04F15"/>
-              </a:solidFill>
-              <a:prstDash val="solid"/>
-              <a:miter/>
-            </a:ln>
-          </p:spPr>
-          <p:txBody>
-            <a:bodyPr/>
-            <a:lstStyle/>
-            <a:p>
-              <a:endParaRPr lang="en-US"/>
-            </a:p>
-          </p:txBody>
-        </p:sp>
-      </p:grpSp>
+            <a:r>
+              <a:rPr lang="en-US" sz="11000" dirty="0">
+                <a:solidFill>
+                  <a:srgbClr val="6BA7C9"/>
+                </a:solidFill>
+                <a:latin typeface="ESRI Surveyor" panose="02000000000000000000" pitchFamily="2" charset="0"/>
+              </a:rPr>
+              <a:t>i</a:t>
+            </a:r>
+          </a:p>
+        </p:txBody>
+      </p:sp>
     </p:spTree>
     <p:extLst>
       <p:ext uri="{BB962C8B-B14F-4D97-AF65-F5344CB8AC3E}">

</xml_diff>